<commit_message>
Docs : auteur, mention de Claude Code et licence de la documentation
- « Développé par Jonathan Desaulniers » et « Claude Code d'Anthropic a été
  utilisé dans la programmation du plugin » (README, section Auteur et licences).
- Code : GPL-3.0-or-later inchangée (exigée par Moodle).
- Documentation (et présentation sur main) : CC BY-SA 4.0, LICENSE-DOCS.md.
</commit_message>
<xml_diff>
--- a/docs/qtype_webwork_presentation.pptx
+++ b/docs/qtype_webwork_presentation.pptx
@@ -15193,6 +15193,67 @@
               <a:t>qtype_webwork  +  qbehaviour_webwork  +  qbank_webworkimport  —  Moodle 4.1 · 4.5 · 5.3</a:t>
             </a:r>
             <a:endParaRPr lang="en-US" sz="1100" dirty="0"/>
+          </a:p>
+        </p:txBody>
+      </p:sp>
+      <p:sp>
+        <p:nvSpPr>
+          <p:cNvPr id="10" name="Credits">
+            <a:extLst>
+              <a:ext uri="{FF2B5EF4-FFF2-40B4-BE49-F238E27FC236}">
+                <a16:creationId xmlns:a16="http://schemas.microsoft.com/office/drawing/2014/main" id="{4C66BAA0-F5E0-FC55-615B-CFDEBD649924}"/>
+              </a:ext>
+            </a:extLst>
+          </p:cNvPr>
+          <p:cNvSpPr/>
+          <p:nvPr/>
+        </p:nvSpPr>
+        <p:spPr>
+          <a:xfrm>
+            <a:off x="0" y="4978400"/>
+            <a:ext cx="12192000" cy="584200"/>
+          </a:xfrm>
+          <a:prstGeom prst="rect">
+            <a:avLst/>
+          </a:prstGeom>
+          <a:noFill/>
+          <a:ln/>
+        </p:spPr>
+        <p:txBody>
+          <a:bodyPr wrap="square" rtlCol="0" anchor="ctr"/>
+          <a:lstStyle/>
+          <a:p>
+            <a:pPr marL="0" indent="0" algn="ctr">
+              <a:buNone/>
+            </a:pPr>
+            <a:r>
+              <a:rPr lang="fr-CA" sz="1200">
+                <a:solidFill>
+                  <a:srgbClr val="9FB0C3"/>
+                </a:solidFill>
+                <a:latin typeface="Calibri" pitchFamily="34" charset="0"/>
+                <a:ea typeface="Calibri" pitchFamily="34" charset="-122"/>
+                <a:cs typeface="Calibri" pitchFamily="34" charset="-120"/>
+              </a:rPr>
+              <a:t>Développé par Jonathan Desaulniers — Claude Code d’Anthropic a été utilisé dans la programmation du plugin</a:t>
+            </a:r>
+          </a:p>
+          <a:p>
+            <a:pPr marL="0" indent="0" algn="ctr">
+              <a:buNone/>
+            </a:pPr>
+            <a:r>
+              <a:rPr lang="fr-CA" sz="1200" i="1">
+                <a:solidFill>
+                  <a:srgbClr val="9FB0C3"/>
+                </a:solidFill>
+                <a:latin typeface="Calibri" pitchFamily="34" charset="0"/>
+                <a:ea typeface="Calibri" pitchFamily="34" charset="-122"/>
+                <a:cs typeface="Calibri" pitchFamily="34" charset="-120"/>
+              </a:rPr>
+              <a:t>Documentation et présentation : CC BY-SA 4.0  ·  Code : GPL-3.0-or-later</a:t>
+            </a:r>
+            <a:endParaRPr lang="en-US" sz="1200" dirty="0"/>
           </a:p>
         </p:txBody>
       </p:sp>

</xml_diff>